<commit_message>
Scenario 2: switch the note to a buffered autocall (70% barrier + embedded 70% put), 10.50% coupon
Pricer: maturity pays 100% above 70%, else 70%; new design rows, put-pair value split,
floor statistics. Product deck, thesis slides and strategy write-up updated.

Co-Authored-By: Claude Opus 5.5 <noreply@anthropic.com>
Claude-Session: https://claude.ai/code/session_01Rwoh8cFDQqLD8JWT3mee6y
</commit_message>
<xml_diff>
--- a/deck/Investment-Thesis-Factors.pptx
+++ b/deck/Investment-Thesis-Factors.pptx
@@ -5468,7 +5468,7 @@
                 <a:ea typeface="Arial" pitchFamily="34" charset="-122"/>
                 <a:cs typeface="Arial" pitchFamily="34" charset="-120"/>
               </a:rPr>
-              <a:t>A zero-cost collar (buy the 70% put, sell a ≈248% call) lifts the worst 1% to USD 70mn and keeps the median at 113.</a:t>
+              <a:t>A 70% put lifts the worst 1% to USD 70mn. Our note embeds it: 10.5% memory coupon, 100% back above 70%, never less than 70%.</a:t>
             </a:r>
             <a:endParaRPr lang="en-US" sz="1000" dirty="0"/>
           </a:p>
@@ -5507,7 +5507,7 @@
                 <a:ea typeface="Arial" pitchFamily="34" charset="-122"/>
                 <a:cs typeface="Arial" pitchFamily="34" charset="-120"/>
               </a:rPr>
-              <a:t>Realised vol: 63-day daily returns of the buy-and-hold portfolio; 5-year average of that series 22% (weekly-return vol 24.5%). Correlation: 13-week weekly returns. Collar priced in the team Monte Carlo without volatility skew (real quotes will be dearer).</a:t>
+              <a:t>Realised vol: 63-day daily returns of the buy-and-hold portfolio; 5-year average of that series 22% (weekly-return vol 24.5%). Correlation: 13-week weekly returns. Put and note priced in the team Monte Carlo without volatility skew (real quotes will be dearer).</a:t>
             </a:r>
             <a:endParaRPr lang="en-US" sz="800" dirty="0"/>
           </a:p>

</xml_diff>